<commit_message>
Update and upload lecture slides (mod4 & 5)
</commit_message>
<xml_diff>
--- a/seminar_slides_2025/M4-2_Intro_Mapping__07-2025.pptx
+++ b/seminar_slides_2025/M4-2_Intro_Mapping__07-2025.pptx
@@ -372,7 +372,7 @@
           <a:p>
             <a:fld id="{9A8302B7-B1BF-424D-814E-7353C3A0E584}" type="datetimeFigureOut">
               <a:rPr lang="en-US" smtClean="0"/>
-              <a:t>7/7/25</a:t>
+              <a:t>7/9/25</a:t>
             </a:fld>
             <a:endParaRPr lang="en-US"/>
           </a:p>
@@ -34623,6 +34623,45 @@
                 <a:sym typeface="Helvetica Neue"/>
               </a:rPr>
               <a:t>Introduction to Mapping</a:t>
+            </a:r>
+          </a:p>
+        </p:txBody>
+      </p:sp>
+      <p:sp>
+        <p:nvSpPr>
+          <p:cNvPr id="2" name="TextBox 1">
+            <a:extLst>
+              <a:ext uri="{FF2B5EF4-FFF2-40B4-BE49-F238E27FC236}">
+                <a16:creationId xmlns:a16="http://schemas.microsoft.com/office/drawing/2014/main" id="{69C2AA00-0679-64EA-5B74-107C3EF55998}"/>
+              </a:ext>
+            </a:extLst>
+          </p:cNvPr>
+          <p:cNvSpPr txBox="1"/>
+          <p:nvPr/>
+        </p:nvSpPr>
+        <p:spPr>
+          <a:xfrm>
+            <a:off x="6258582" y="4835723"/>
+            <a:ext cx="990977" cy="307777"/>
+          </a:xfrm>
+          <a:prstGeom prst="rect">
+            <a:avLst/>
+          </a:prstGeom>
+          <a:noFill/>
+        </p:spPr>
+        <p:txBody>
+          <a:bodyPr wrap="none" rtlCol="0">
+            <a:spAutoFit/>
+          </a:bodyPr>
+          <a:lstStyle/>
+          <a:p>
+            <a:r>
+              <a:rPr lang="en-GB" sz="1400" dirty="0">
+                <a:solidFill>
+                  <a:schemeClr val="bg1"/>
+                </a:solidFill>
+              </a:rPr>
+              <a:t>Mat Beale</a:t>
             </a:r>
           </a:p>
         </p:txBody>

</xml_diff>